<commit_message>
Added demo link to ppt
</commit_message>
<xml_diff>
--- a/demo/WealthWise_Automatic_Release_Notes.pptx
+++ b/demo/WealthWise_Automatic_Release_Notes.pptx
@@ -2489,6 +2489,7 @@
       <p:pic>
         <p:nvPicPr>
           <p:cNvPr id="9" name="Graphic 8" descr="Chevron arrows with solid fill">
+            <a:hlinkClick r:id="rId3"/>
             <a:extLst>
               <a:ext uri="{FF2B5EF4-FFF2-40B4-BE49-F238E27FC236}">
                 <a16:creationId xmlns:a16="http://schemas.microsoft.com/office/drawing/2014/main" id="{679518DA-CEB9-3585-8487-A36ECED7A6E2}"/>
@@ -2504,7 +2505,7 @@
           <a:blip>
             <a:extLst>
               <a:ext uri="{96DAC541-7B7A-43D3-8B79-37D633B846F1}">
-                <asvg:svgBlip xmlns:asvg="http://schemas.microsoft.com/office/drawing/2016/SVG/main" r:embed="rId3"/>
+                <asvg:svgBlip xmlns:asvg="http://schemas.microsoft.com/office/drawing/2016/SVG/main" r:embed="rId4"/>
               </a:ext>
             </a:extLst>
           </a:blip>
@@ -2514,7 +2515,7 @@
         </p:blipFill>
         <p:spPr>
           <a:xfrm>
-            <a:off x="5181600" y="2935224"/>
+            <a:off x="5074920" y="3025386"/>
             <a:ext cx="914400" cy="914400"/>
           </a:xfrm>
           <a:prstGeom prst="rect">
@@ -2522,6 +2523,50 @@
           </a:prstGeom>
         </p:spPr>
       </p:pic>
+      <p:sp>
+        <p:nvSpPr>
+          <p:cNvPr id="12" name="TextBox 11">
+            <a:extLst>
+              <a:ext uri="{FF2B5EF4-FFF2-40B4-BE49-F238E27FC236}">
+                <a16:creationId xmlns:a16="http://schemas.microsoft.com/office/drawing/2014/main" id="{A6E2EA4D-25B3-3BA9-4F16-E5F73ECB9E83}"/>
+              </a:ext>
+            </a:extLst>
+          </p:cNvPr>
+          <p:cNvSpPr txBox="1"/>
+          <p:nvPr/>
+        </p:nvSpPr>
+        <p:spPr>
+          <a:xfrm>
+            <a:off x="3616960" y="2217142"/>
+            <a:ext cx="4297680" cy="369332"/>
+          </a:xfrm>
+          <a:prstGeom prst="rect">
+            <a:avLst/>
+          </a:prstGeom>
+          <a:noFill/>
+        </p:spPr>
+        <p:txBody>
+          <a:bodyPr wrap="square" rtlCol="0">
+            <a:spAutoFit/>
+          </a:bodyPr>
+          <a:lstStyle/>
+          <a:p>
+            <a:r>
+              <a:rPr lang="en-IN" b="1" dirty="0" err="1"/>
+              <a:t>Ctrl+click</a:t>
+            </a:r>
+            <a:r>
+              <a:rPr lang="en-IN" b="1" dirty="0"/>
+              <a:t> </a:t>
+            </a:r>
+            <a:r>
+              <a:rPr lang="en-IN" dirty="0"/>
+              <a:t>the arrow to watch the video!</a:t>
+            </a:r>
+            <a:endParaRPr lang="pa-IN" dirty="0"/>
+          </a:p>
+        </p:txBody>
+      </p:sp>
     </p:spTree>
     <p:extLst>
       <p:ext uri="{BB962C8B-B14F-4D97-AF65-F5344CB8AC3E}">

</xml_diff>